<commit_message>
docs: update SYSTEM.md with clarifications and constraints
- Add temporary file cleanup requirement
- Add DO NOT USE CLOSURES rule
- Clarify context management approach
- Clarify USER_PREFS.md update conditions
- Specify third-party agents context for user requests
- Remove unused VS Code extension binary
</commit_message>
<xml_diff>
--- a/papers/kisssorcar/KISS_Sorcar_Lecture.pptx
+++ b/papers/kisssorcar/KISS_Sorcar_Lecture.pptx
@@ -28263,7 +28263,7 @@
           <a:bodyPr rtlCol="0" anchor="ctr" wrap="square" lIns="274320" rIns="274320" tIns="182880" bIns="182880"/>
           <a:lstStyle/>
           <a:p>
-            <a:pPr algn="ctr">
+            <a:pPr algn="l">
               <a:lnSpc>
                 <a:spcPts val="1800"/>
               </a:lnSpc>
@@ -28275,11 +28275,44 @@
               </a:defRPr>
             </a:pPr>
             <a:r>
-              <a:t>from kiss.core.kiss_agent import KISSAgent</a:t>
-            </a:r>
-          </a:p>
-          <a:p>
-            <a:pPr>
+              <a:rPr lang="en-US" sz="1300" dirty="0">
+                <a:solidFill>
+                  <a:srgbClr val="C678DD"/>
+                </a:solidFill>
+                <a:latin typeface="Courier New"/>
+              </a:rPr>
+              <a:t>from</a:t>
+            </a:r>
+            <a:r>
+              <a:rPr lang="en-US" sz="1300" dirty="0">
+                <a:solidFill>
+                  <a:srgbClr val="E2E8F0"/>
+                </a:solidFill>
+                <a:latin typeface="Courier New"/>
+              </a:rPr>
+              <a:t> kiss.core.kiss_agent </a:t>
+            </a:r>
+            <a:r>
+              <a:rPr lang="en-US" sz="1300" dirty="0">
+                <a:solidFill>
+                  <a:srgbClr val="C678DD"/>
+                </a:solidFill>
+                <a:latin typeface="Courier New"/>
+              </a:rPr>
+              <a:t>import</a:t>
+            </a:r>
+            <a:r>
+              <a:rPr lang="en-US" sz="1300" dirty="0">
+                <a:solidFill>
+                  <a:srgbClr val="E2E8F0"/>
+                </a:solidFill>
+                <a:latin typeface="Courier New"/>
+              </a:rPr>
+              <a:t> KISSAgent</a:t>
+            </a:r>
+          </a:p>
+          <a:p>
+            <a:pPr algn="l">
               <a:lnSpc>
                 <a:spcPts val="1800"/>
               </a:lnSpc>
@@ -28290,9 +28323,15 @@
                 <a:latin typeface="Courier New"/>
               </a:defRPr>
             </a:pPr>
-          </a:p>
-          <a:p>
-            <a:pPr>
+            <a:endParaRPr sz="1300">
+              <a:solidFill>
+                <a:srgbClr val="E2E8F0"/>
+              </a:solidFill>
+              <a:latin typeface="Courier New"/>
+            </a:endParaRPr>
+          </a:p>
+          <a:p>
+            <a:pPr algn="l">
               <a:lnSpc>
                 <a:spcPts val="1800"/>
               </a:lnSpc>
@@ -28304,11 +28343,134 @@
               </a:defRPr>
             </a:pPr>
             <a:r>
-              <a:t>def calculate(expression: str) -&gt; str:</a:t>
-            </a:r>
-          </a:p>
-          <a:p>
-            <a:pPr>
+              <a:rPr lang="en-US" sz="1300" dirty="0">
+                <a:solidFill>
+                  <a:srgbClr val="C678DD"/>
+                </a:solidFill>
+                <a:latin typeface="Courier New"/>
+              </a:rPr>
+              <a:t>def</a:t>
+            </a:r>
+            <a:r>
+              <a:rPr lang="en-US" sz="1300" dirty="0">
+                <a:solidFill>
+                  <a:srgbClr val="E2E8F0"/>
+                </a:solidFill>
+                <a:latin typeface="Courier New"/>
+              </a:rPr>
+              <a:t> </a:t>
+            </a:r>
+            <a:r>
+              <a:rPr lang="en-US" sz="1300" dirty="0">
+                <a:solidFill>
+                  <a:srgbClr val="61AFEF"/>
+                </a:solidFill>
+                <a:latin typeface="Courier New"/>
+              </a:rPr>
+              <a:t>calculate</a:t>
+            </a:r>
+            <a:r>
+              <a:rPr lang="en-US" sz="1300" dirty="0">
+                <a:solidFill>
+                  <a:srgbClr val="ABB2BF"/>
+                </a:solidFill>
+                <a:latin typeface="Courier New"/>
+              </a:rPr>
+              <a:t>(</a:t>
+            </a:r>
+            <a:r>
+              <a:rPr lang="en-US" sz="1300" dirty="0">
+                <a:solidFill>
+                  <a:srgbClr val="E2E8F0"/>
+                </a:solidFill>
+                <a:latin typeface="Courier New"/>
+              </a:rPr>
+              <a:t>expression</a:t>
+            </a:r>
+            <a:r>
+              <a:rPr lang="en-US" sz="1300" dirty="0">
+                <a:solidFill>
+                  <a:srgbClr val="ABB2BF"/>
+                </a:solidFill>
+                <a:latin typeface="Courier New"/>
+              </a:rPr>
+              <a:t>:</a:t>
+            </a:r>
+            <a:r>
+              <a:rPr lang="en-US" sz="1300" dirty="0">
+                <a:solidFill>
+                  <a:srgbClr val="E2E8F0"/>
+                </a:solidFill>
+                <a:latin typeface="Courier New"/>
+              </a:rPr>
+              <a:t> </a:t>
+            </a:r>
+            <a:r>
+              <a:rPr lang="en-US" sz="1300" dirty="0">
+                <a:solidFill>
+                  <a:srgbClr val="61AFEF"/>
+                </a:solidFill>
+                <a:latin typeface="Courier New"/>
+              </a:rPr>
+              <a:t>str</a:t>
+            </a:r>
+            <a:r>
+              <a:rPr lang="en-US" sz="1300" dirty="0">
+                <a:solidFill>
+                  <a:srgbClr val="ABB2BF"/>
+                </a:solidFill>
+                <a:latin typeface="Courier New"/>
+              </a:rPr>
+              <a:t>)</a:t>
+            </a:r>
+            <a:r>
+              <a:rPr lang="en-US" sz="1300" dirty="0">
+                <a:solidFill>
+                  <a:srgbClr val="E2E8F0"/>
+                </a:solidFill>
+                <a:latin typeface="Courier New"/>
+              </a:rPr>
+              <a:t> </a:t>
+            </a:r>
+            <a:r>
+              <a:rPr lang="en-US" sz="1300" dirty="0">
+                <a:solidFill>
+                  <a:srgbClr val="56B6C2"/>
+                </a:solidFill>
+                <a:latin typeface="Courier New"/>
+              </a:rPr>
+              <a:t>-&gt;</a:t>
+            </a:r>
+            <a:r>
+              <a:rPr lang="en-US" sz="1300" dirty="0">
+                <a:solidFill>
+                  <a:srgbClr val="E2E8F0"/>
+                </a:solidFill>
+                <a:latin typeface="Courier New"/>
+              </a:rPr>
+              <a:t> </a:t>
+            </a:r>
+            <a:r>
+              <a:rPr lang="en-US" sz="1300" dirty="0">
+                <a:solidFill>
+                  <a:srgbClr val="61AFEF"/>
+                </a:solidFill>
+                <a:latin typeface="Courier New"/>
+              </a:rPr>
+              <a:t>str</a:t>
+            </a:r>
+            <a:r>
+              <a:rPr lang="en-US" sz="1300" dirty="0">
+                <a:solidFill>
+                  <a:srgbClr val="ABB2BF"/>
+                </a:solidFill>
+                <a:latin typeface="Courier New"/>
+              </a:rPr>
+              <a:t>:</a:t>
+            </a:r>
+          </a:p>
+          <a:p>
+            <a:pPr algn="l">
               <a:lnSpc>
                 <a:spcPts val="1800"/>
               </a:lnSpc>
@@ -28320,11 +28482,26 @@
               </a:defRPr>
             </a:pPr>
             <a:r>
-              <a:t>    """Evaluate a math expression."""</a:t>
-            </a:r>
-          </a:p>
-          <a:p>
-            <a:pPr>
+              <a:rPr lang="en-US" sz="1300" dirty="0">
+                <a:solidFill>
+                  <a:srgbClr val="E2E8F0"/>
+                </a:solidFill>
+                <a:latin typeface="Courier New"/>
+              </a:rPr>
+              <a:t>    </a:t>
+            </a:r>
+            <a:r>
+              <a:rPr lang="en-US" sz="1300" dirty="0">
+                <a:solidFill>
+                  <a:srgbClr val="98C379"/>
+                </a:solidFill>
+                <a:latin typeface="Courier New"/>
+              </a:rPr>
+              <a:t>"""Evaluate a math expression."""</a:t>
+            </a:r>
+          </a:p>
+          <a:p>
+            <a:pPr algn="l">
               <a:lnSpc>
                 <a:spcPts val="1800"/>
               </a:lnSpc>
@@ -28336,11 +28513,89 @@
               </a:defRPr>
             </a:pPr>
             <a:r>
-              <a:t>    return str(eval(expression))</a:t>
-            </a:r>
-          </a:p>
-          <a:p>
-            <a:pPr>
+              <a:rPr lang="en-US" sz="1300" dirty="0">
+                <a:solidFill>
+                  <a:srgbClr val="E2E8F0"/>
+                </a:solidFill>
+                <a:latin typeface="Courier New"/>
+              </a:rPr>
+              <a:t>    </a:t>
+            </a:r>
+            <a:r>
+              <a:rPr lang="en-US" sz="1300" dirty="0">
+                <a:solidFill>
+                  <a:srgbClr val="C678DD"/>
+                </a:solidFill>
+                <a:latin typeface="Courier New"/>
+              </a:rPr>
+              <a:t>return</a:t>
+            </a:r>
+            <a:r>
+              <a:rPr lang="en-US" sz="1300" dirty="0">
+                <a:solidFill>
+                  <a:srgbClr val="E2E8F0"/>
+                </a:solidFill>
+                <a:latin typeface="Courier New"/>
+              </a:rPr>
+              <a:t> </a:t>
+            </a:r>
+            <a:r>
+              <a:rPr lang="en-US" sz="1300" dirty="0">
+                <a:solidFill>
+                  <a:srgbClr val="61AFEF"/>
+                </a:solidFill>
+                <a:latin typeface="Courier New"/>
+              </a:rPr>
+              <a:t>str</a:t>
+            </a:r>
+            <a:r>
+              <a:rPr lang="en-US" sz="1300" dirty="0">
+                <a:solidFill>
+                  <a:srgbClr val="ABB2BF"/>
+                </a:solidFill>
+                <a:latin typeface="Courier New"/>
+              </a:rPr>
+              <a:t>(</a:t>
+            </a:r>
+            <a:r>
+              <a:rPr lang="en-US" sz="1300" dirty="0">
+                <a:solidFill>
+                  <a:srgbClr val="61AFEF"/>
+                </a:solidFill>
+                <a:latin typeface="Courier New"/>
+              </a:rPr>
+              <a:t>eval</a:t>
+            </a:r>
+            <a:r>
+              <a:rPr lang="en-US" sz="1300" dirty="0">
+                <a:solidFill>
+                  <a:srgbClr val="ABB2BF"/>
+                </a:solidFill>
+                <a:latin typeface="Courier New"/>
+              </a:rPr>
+              <a:t>(</a:t>
+            </a:r>
+            <a:r>
+              <a:rPr lang="en-US" sz="1300" dirty="0">
+                <a:solidFill>
+                  <a:srgbClr val="E2E8F0"/>
+                </a:solidFill>
+                <a:latin typeface="Courier New"/>
+              </a:rPr>
+              <a:t>expression</a:t>
+            </a:r>
+            <a:r>
+              <a:rPr lang="en-US" sz="1300" dirty="0">
+                <a:solidFill>
+                  <a:srgbClr val="ABB2BF"/>
+                </a:solidFill>
+                <a:latin typeface="Courier New"/>
+              </a:rPr>
+              <a:t>))</a:t>
+            </a:r>
+          </a:p>
+          <a:p>
+            <a:pPr algn="l">
               <a:lnSpc>
                 <a:spcPts val="1800"/>
               </a:lnSpc>
@@ -28351,9 +28606,15 @@
                 <a:latin typeface="Courier New"/>
               </a:defRPr>
             </a:pPr>
-          </a:p>
-          <a:p>
-            <a:pPr>
+            <a:endParaRPr sz="1300">
+              <a:solidFill>
+                <a:srgbClr val="E2E8F0"/>
+              </a:solidFill>
+              <a:latin typeface="Courier New"/>
+            </a:endParaRPr>
+          </a:p>
+          <a:p>
+            <a:pPr algn="l">
               <a:lnSpc>
                 <a:spcPts val="1800"/>
               </a:lnSpc>
@@ -28365,11 +28626,80 @@
               </a:defRPr>
             </a:pPr>
             <a:r>
-              <a:t>agent = KISSAgent(name="Math Buddy")</a:t>
-            </a:r>
-          </a:p>
-          <a:p>
-            <a:pPr>
+              <a:rPr lang="en-US" sz="1300" dirty="0">
+                <a:solidFill>
+                  <a:srgbClr val="E2E8F0"/>
+                </a:solidFill>
+                <a:latin typeface="Courier New"/>
+              </a:rPr>
+              <a:t>agent </a:t>
+            </a:r>
+            <a:r>
+              <a:rPr lang="en-US" sz="1300" dirty="0">
+                <a:solidFill>
+                  <a:srgbClr val="56B6C2"/>
+                </a:solidFill>
+                <a:latin typeface="Courier New"/>
+              </a:rPr>
+              <a:t>=</a:t>
+            </a:r>
+            <a:r>
+              <a:rPr lang="en-US" sz="1300" dirty="0">
+                <a:solidFill>
+                  <a:srgbClr val="E2E8F0"/>
+                </a:solidFill>
+                <a:latin typeface="Courier New"/>
+              </a:rPr>
+              <a:t> KISSAgent</a:t>
+            </a:r>
+            <a:r>
+              <a:rPr lang="en-US" sz="1300" dirty="0">
+                <a:solidFill>
+                  <a:srgbClr val="ABB2BF"/>
+                </a:solidFill>
+                <a:latin typeface="Courier New"/>
+              </a:rPr>
+              <a:t>(</a:t>
+            </a:r>
+            <a:r>
+              <a:rPr lang="en-US" sz="1300" dirty="0">
+                <a:solidFill>
+                  <a:srgbClr val="E2E8F0"/>
+                </a:solidFill>
+                <a:latin typeface="Courier New"/>
+              </a:rPr>
+              <a:t>name</a:t>
+            </a:r>
+            <a:r>
+              <a:rPr lang="en-US" sz="1300" dirty="0">
+                <a:solidFill>
+                  <a:srgbClr val="56B6C2"/>
+                </a:solidFill>
+                <a:latin typeface="Courier New"/>
+              </a:rPr>
+              <a:t>=</a:t>
+            </a:r>
+            <a:r>
+              <a:rPr lang="en-US" sz="1300" dirty="0">
+                <a:solidFill>
+                  <a:srgbClr val="98C379"/>
+                </a:solidFill>
+                <a:latin typeface="Courier New"/>
+              </a:rPr>
+              <a:t>"Math Buddy"</a:t>
+            </a:r>
+            <a:r>
+              <a:rPr lang="en-US" sz="1300" dirty="0">
+                <a:solidFill>
+                  <a:srgbClr val="ABB2BF"/>
+                </a:solidFill>
+                <a:latin typeface="Courier New"/>
+              </a:rPr>
+              <a:t>)</a:t>
+            </a:r>
+          </a:p>
+          <a:p>
+            <a:pPr algn="l">
               <a:lnSpc>
                 <a:spcPts val="1800"/>
               </a:lnSpc>
@@ -28381,11 +28711,62 @@
               </a:defRPr>
             </a:pPr>
             <a:r>
-              <a:t>result = agent.run(</a:t>
-            </a:r>
-          </a:p>
-          <a:p>
-            <a:pPr>
+              <a:rPr lang="en-US" sz="1300" dirty="0">
+                <a:solidFill>
+                  <a:srgbClr val="E2E8F0"/>
+                </a:solidFill>
+                <a:latin typeface="Courier New"/>
+              </a:rPr>
+              <a:t>result </a:t>
+            </a:r>
+            <a:r>
+              <a:rPr lang="en-US" sz="1300" dirty="0">
+                <a:solidFill>
+                  <a:srgbClr val="56B6C2"/>
+                </a:solidFill>
+                <a:latin typeface="Courier New"/>
+              </a:rPr>
+              <a:t>=</a:t>
+            </a:r>
+            <a:r>
+              <a:rPr lang="en-US" sz="1300" dirty="0">
+                <a:solidFill>
+                  <a:srgbClr val="E2E8F0"/>
+                </a:solidFill>
+                <a:latin typeface="Courier New"/>
+              </a:rPr>
+              <a:t> agent</a:t>
+            </a:r>
+            <a:r>
+              <a:rPr lang="en-US" sz="1300" dirty="0">
+                <a:solidFill>
+                  <a:srgbClr val="56B6C2"/>
+                </a:solidFill>
+                <a:latin typeface="Courier New"/>
+              </a:rPr>
+              <a:t>.</a:t>
+            </a:r>
+            <a:r>
+              <a:rPr lang="en-US" sz="1300" dirty="0">
+                <a:solidFill>
+                  <a:srgbClr val="E2E8F0"/>
+                </a:solidFill>
+                <a:latin typeface="Courier New"/>
+              </a:rPr>
+              <a:t>run</a:t>
+            </a:r>
+            <a:r>
+              <a:rPr lang="en-US" sz="1300" dirty="0">
+                <a:solidFill>
+                  <a:srgbClr val="ABB2BF"/>
+                </a:solidFill>
+                <a:latin typeface="Courier New"/>
+              </a:rPr>
+              <a:t>(</a:t>
+            </a:r>
+          </a:p>
+          <a:p>
+            <a:pPr algn="l">
               <a:lnSpc>
                 <a:spcPts val="1800"/>
               </a:lnSpc>
@@ -28397,11 +28778,44 @@
               </a:defRPr>
             </a:pPr>
             <a:r>
-              <a:t>    model_name="gemini-2.5-flash",</a:t>
-            </a:r>
-          </a:p>
-          <a:p>
-            <a:pPr>
+              <a:rPr lang="en-US" sz="1300" dirty="0">
+                <a:solidFill>
+                  <a:srgbClr val="E2E8F0"/>
+                </a:solidFill>
+                <a:latin typeface="Courier New"/>
+              </a:rPr>
+              <a:t>    model_name</a:t>
+            </a:r>
+            <a:r>
+              <a:rPr lang="en-US" sz="1300" dirty="0">
+                <a:solidFill>
+                  <a:srgbClr val="56B6C2"/>
+                </a:solidFill>
+                <a:latin typeface="Courier New"/>
+              </a:rPr>
+              <a:t>=</a:t>
+            </a:r>
+            <a:r>
+              <a:rPr lang="en-US" sz="1300" dirty="0">
+                <a:solidFill>
+                  <a:srgbClr val="98C379"/>
+                </a:solidFill>
+                <a:latin typeface="Courier New"/>
+              </a:rPr>
+              <a:t>"gemini-2.5-flash"</a:t>
+            </a:r>
+            <a:r>
+              <a:rPr lang="en-US" sz="1300" dirty="0">
+                <a:solidFill>
+                  <a:srgbClr val="ABB2BF"/>
+                </a:solidFill>
+                <a:latin typeface="Courier New"/>
+              </a:rPr>
+              <a:t>,</a:t>
+            </a:r>
+          </a:p>
+          <a:p>
+            <a:pPr algn="l">
               <a:lnSpc>
                 <a:spcPts val="1800"/>
               </a:lnSpc>
@@ -28413,11 +28827,62 @@
               </a:defRPr>
             </a:pPr>
             <a:r>
-              <a:t>    prompt_template="Calculate: {question}",</a:t>
-            </a:r>
-          </a:p>
-          <a:p>
-            <a:pPr>
+              <a:rPr lang="en-US" sz="1300" dirty="0">
+                <a:solidFill>
+                  <a:srgbClr val="E2E8F0"/>
+                </a:solidFill>
+                <a:latin typeface="Courier New"/>
+              </a:rPr>
+              <a:t>    prompt_template</a:t>
+            </a:r>
+            <a:r>
+              <a:rPr lang="en-US" sz="1300" dirty="0">
+                <a:solidFill>
+                  <a:srgbClr val="56B6C2"/>
+                </a:solidFill>
+                <a:latin typeface="Courier New"/>
+              </a:rPr>
+              <a:t>=</a:t>
+            </a:r>
+            <a:r>
+              <a:rPr lang="en-US" sz="1300" dirty="0">
+                <a:solidFill>
+                  <a:srgbClr val="98C379"/>
+                </a:solidFill>
+                <a:latin typeface="Courier New"/>
+              </a:rPr>
+              <a:t>"Calculate: </a:t>
+            </a:r>
+            <a:r>
+              <a:rPr lang="en-US" sz="1300" dirty="0">
+                <a:solidFill>
+                  <a:srgbClr val="D19A66"/>
+                </a:solidFill>
+                <a:latin typeface="Courier New"/>
+              </a:rPr>
+              <a:t>{question}</a:t>
+            </a:r>
+            <a:r>
+              <a:rPr lang="en-US" sz="1300" dirty="0">
+                <a:solidFill>
+                  <a:srgbClr val="98C379"/>
+                </a:solidFill>
+                <a:latin typeface="Courier New"/>
+              </a:rPr>
+              <a:t>"</a:t>
+            </a:r>
+            <a:r>
+              <a:rPr lang="en-US" sz="1300" dirty="0">
+                <a:solidFill>
+                  <a:srgbClr val="ABB2BF"/>
+                </a:solidFill>
+                <a:latin typeface="Courier New"/>
+              </a:rPr>
+              <a:t>,</a:t>
+            </a:r>
+          </a:p>
+          <a:p>
+            <a:pPr algn="l">
               <a:lnSpc>
                 <a:spcPts val="1800"/>
               </a:lnSpc>
@@ -28429,11 +28894,98 @@
               </a:defRPr>
             </a:pPr>
             <a:r>
-              <a:t>    arguments={"question": "What is 15% of 847?"},</a:t>
-            </a:r>
-          </a:p>
-          <a:p>
-            <a:pPr>
+              <a:rPr lang="en-US" sz="1300" dirty="0">
+                <a:solidFill>
+                  <a:srgbClr val="E2E8F0"/>
+                </a:solidFill>
+                <a:latin typeface="Courier New"/>
+              </a:rPr>
+              <a:t>    arguments</a:t>
+            </a:r>
+            <a:r>
+              <a:rPr lang="en-US" sz="1300" dirty="0">
+                <a:solidFill>
+                  <a:srgbClr val="56B6C2"/>
+                </a:solidFill>
+                <a:latin typeface="Courier New"/>
+              </a:rPr>
+              <a:t>=</a:t>
+            </a:r>
+            <a:r>
+              <a:rPr lang="en-US" sz="1300" dirty="0">
+                <a:solidFill>
+                  <a:srgbClr val="ABB2BF"/>
+                </a:solidFill>
+                <a:latin typeface="Courier New"/>
+              </a:rPr>
+              <a:t>{</a:t>
+            </a:r>
+            <a:r>
+              <a:rPr lang="en-US" sz="1300" dirty="0">
+                <a:solidFill>
+                  <a:srgbClr val="98C379"/>
+                </a:solidFill>
+                <a:latin typeface="Courier New"/>
+              </a:rPr>
+              <a:t>"question"</a:t>
+            </a:r>
+            <a:r>
+              <a:rPr lang="en-US" sz="1300" dirty="0">
+                <a:solidFill>
+                  <a:srgbClr val="ABB2BF"/>
+                </a:solidFill>
+                <a:latin typeface="Courier New"/>
+              </a:rPr>
+              <a:t>:</a:t>
+            </a:r>
+            <a:r>
+              <a:rPr lang="en-US" sz="1300" dirty="0">
+                <a:solidFill>
+                  <a:srgbClr val="E2E8F0"/>
+                </a:solidFill>
+                <a:latin typeface="Courier New"/>
+              </a:rPr>
+              <a:t> </a:t>
+            </a:r>
+            <a:r>
+              <a:rPr lang="en-US" sz="1300" dirty="0">
+                <a:solidFill>
+                  <a:srgbClr val="98C379"/>
+                </a:solidFill>
+                <a:latin typeface="Courier New"/>
+              </a:rPr>
+              <a:t>"What is 15</a:t>
+            </a:r>
+            <a:r>
+              <a:rPr lang="en-US" sz="1300" dirty="0">
+                <a:solidFill>
+                  <a:srgbClr val="D19A66"/>
+                </a:solidFill>
+                <a:latin typeface="Courier New"/>
+              </a:rPr>
+              <a:t>% o</a:t>
+            </a:r>
+            <a:r>
+              <a:rPr lang="en-US" sz="1300" dirty="0">
+                <a:solidFill>
+                  <a:srgbClr val="98C379"/>
+                </a:solidFill>
+                <a:latin typeface="Courier New"/>
+              </a:rPr>
+              <a:t>f 847?"</a:t>
+            </a:r>
+            <a:r>
+              <a:rPr lang="en-US" sz="1300" dirty="0">
+                <a:solidFill>
+                  <a:srgbClr val="ABB2BF"/>
+                </a:solidFill>
+                <a:latin typeface="Courier New"/>
+              </a:rPr>
+              <a:t>},</a:t>
+            </a:r>
+          </a:p>
+          <a:p>
+            <a:pPr algn="l">
               <a:lnSpc>
                 <a:spcPts val="1800"/>
               </a:lnSpc>
@@ -28445,11 +28997,53 @@
               </a:defRPr>
             </a:pPr>
             <a:r>
-              <a:t>    tools=[calculate]</a:t>
-            </a:r>
-          </a:p>
-          <a:p>
-            <a:pPr>
+              <a:rPr lang="en-US" sz="1300" dirty="0">
+                <a:solidFill>
+                  <a:srgbClr val="E2E8F0"/>
+                </a:solidFill>
+                <a:latin typeface="Courier New"/>
+              </a:rPr>
+              <a:t>    tools</a:t>
+            </a:r>
+            <a:r>
+              <a:rPr lang="en-US" sz="1300" dirty="0">
+                <a:solidFill>
+                  <a:srgbClr val="56B6C2"/>
+                </a:solidFill>
+                <a:latin typeface="Courier New"/>
+              </a:rPr>
+              <a:t>=</a:t>
+            </a:r>
+            <a:r>
+              <a:rPr lang="en-US" sz="1300" dirty="0">
+                <a:solidFill>
+                  <a:srgbClr val="ABB2BF"/>
+                </a:solidFill>
+                <a:latin typeface="Courier New"/>
+              </a:rPr>
+              <a:t>[</a:t>
+            </a:r>
+            <a:r>
+              <a:rPr lang="en-US" sz="1300" dirty="0">
+                <a:solidFill>
+                  <a:srgbClr val="E2E8F0"/>
+                </a:solidFill>
+                <a:latin typeface="Courier New"/>
+              </a:rPr>
+              <a:t>calculate</a:t>
+            </a:r>
+            <a:r>
+              <a:rPr lang="en-US" sz="1300" dirty="0">
+                <a:solidFill>
+                  <a:srgbClr val="ABB2BF"/>
+                </a:solidFill>
+                <a:latin typeface="Courier New"/>
+              </a:rPr>
+              <a:t>]</a:t>
+            </a:r>
+          </a:p>
+          <a:p>
+            <a:pPr algn="l">
               <a:lnSpc>
                 <a:spcPts val="1800"/>
               </a:lnSpc>
@@ -28461,11 +29055,17 @@
               </a:defRPr>
             </a:pPr>
             <a:r>
+              <a:rPr lang="en-US" sz="1300" dirty="0">
+                <a:solidFill>
+                  <a:srgbClr val="ABB2BF"/>
+                </a:solidFill>
+                <a:latin typeface="Courier New"/>
+              </a:rPr>
               <a:t>)</a:t>
             </a:r>
           </a:p>
           <a:p>
-            <a:pPr>
+            <a:pPr algn="l">
               <a:lnSpc>
                 <a:spcPts val="1800"/>
               </a:lnSpc>
@@ -28477,7 +29077,58 @@
               </a:defRPr>
             </a:pPr>
             <a:r>
-              <a:t>print(result)  # 127.05</a:t>
+              <a:rPr lang="en-US" sz="1300" dirty="0">
+                <a:solidFill>
+                  <a:srgbClr val="61AFEF"/>
+                </a:solidFill>
+                <a:latin typeface="Courier New"/>
+              </a:rPr>
+              <a:t>print</a:t>
+            </a:r>
+            <a:r>
+              <a:rPr lang="en-US" sz="1300" dirty="0">
+                <a:solidFill>
+                  <a:srgbClr val="ABB2BF"/>
+                </a:solidFill>
+                <a:latin typeface="Courier New"/>
+              </a:rPr>
+              <a:t>(</a:t>
+            </a:r>
+            <a:r>
+              <a:rPr lang="en-US" sz="1300" dirty="0">
+                <a:solidFill>
+                  <a:srgbClr val="E2E8F0"/>
+                </a:solidFill>
+                <a:latin typeface="Courier New"/>
+              </a:rPr>
+              <a:t>result</a:t>
+            </a:r>
+            <a:r>
+              <a:rPr lang="en-US" sz="1300" dirty="0">
+                <a:solidFill>
+                  <a:srgbClr val="ABB2BF"/>
+                </a:solidFill>
+                <a:latin typeface="Courier New"/>
+              </a:rPr>
+              <a:t>)</a:t>
+            </a:r>
+            <a:r>
+              <a:rPr lang="en-US" sz="1300" dirty="0">
+                <a:solidFill>
+                  <a:srgbClr val="E2E8F0"/>
+                </a:solidFill>
+                <a:latin typeface="Courier New"/>
+              </a:rPr>
+              <a:t>  </a:t>
+            </a:r>
+            <a:r>
+              <a:rPr lang="en-US" sz="1300" dirty="0">
+                <a:solidFill>
+                  <a:srgbClr val="7F848E"/>
+                </a:solidFill>
+                <a:latin typeface="Courier New"/>
+              </a:rPr>
+              <a:t># 127.05</a:t>
             </a:r>
           </a:p>
         </p:txBody>

</xml_diff>